<commit_message>
Correct two unsupported claims in the presentation
An audit of every figure in the deck against the repository found two claims
that were not backed by a source:

- The title slide dated the release August 2026; CHANGELOG.md records v1.0.0 as
  2026-09-30
- The Clean transfer row of the test table omitted FR-19, so the traceability
  column no longer matched docs/TEST_PLAN.md; widen the column and restore it

Everything else in the deck was verified against source: 11 files and 1,701
lines, serverSession.cpp at 495, the 64 KB chunk and 255-character and 64 GiB
limits in protocol.hpp, the min(4, hardware_concurrency) pool with a floor of 2,
the SSLv2/SSLv3 options in server.cpp, the eight defects in TEST_PLAN.md, and
the 0.03 s / ~267 MB/s / 220 MB / 24 MB / 14,466-byte figures.
</commit_message>
<xml_diff>
--- a/presentation/Secure-Resumable-File-Transfer.pptx
+++ b/presentation/Secure-Resumable-File-Transfer.pptx
@@ -4421,7 +4421,7 @@
                 </a:solidFill>
                 <a:latin typeface="Segoe UI"/>
               </a:rPr>
-              <a:t>Secure Resumable File Transfer  ·  August 2026</a:t>
+              <a:t>Secure Resumable File Transfer  ·  v1.0.0, September 2026</a:t>
             </a:r>
           </a:p>
         </p:txBody>
@@ -5613,7 +5613,7 @@
         </p:nvGraphicFramePr>
         <p:xfrm>
           <a:off x="6656832" y="2542032"/>
-          <a:ext cx="4956047" cy="1993392"/>
+          <a:ext cx="4956048" cy="1993392"/>
         </p:xfrm>
         <a:graphic>
           <a:graphicData uri="http://schemas.openxmlformats.org/drawingml/2006/table">
@@ -5622,9 +5622,9 @@
                 <a:tableStyleId>{5C22544A-7EE6-4342-B048-85BDC9FD1C3A}</a:tableStyleId>
               </a:tblPr>
               <a:tblGrid>
-                <a:gridCol w="2065020"/>
+                <a:gridCol w="1858518"/>
                 <a:gridCol w="894842"/>
-                <a:gridCol w="1996185"/>
+                <a:gridCol w="2202688"/>
               </a:tblGrid>
               <a:tr h="274320">
                 <a:tc>
@@ -5706,7 +5706,7 @@
                         </a:lnSpc>
                       </a:pPr>
                       <a:r>
-                        <a:rPr sz="1000" b="1">
+                        <a:rPr sz="950" b="1">
                           <a:solidFill>
                             <a:srgbClr val="0B1F3A"/>
                           </a:solidFill>
@@ -5733,7 +5733,7 @@
                         </a:lnSpc>
                       </a:pPr>
                       <a:r>
-                        <a:rPr sz="1000" b="0">
+                        <a:rPr sz="950" b="0">
                           <a:solidFill>
                             <a:srgbClr val="4A5568"/>
                           </a:solidFill>
@@ -5760,7 +5760,7 @@
                         </a:lnSpc>
                       </a:pPr>
                       <a:r>
-                        <a:rPr sz="1000" b="0">
+                        <a:rPr sz="950" b="0">
                           <a:solidFill>
                             <a:srgbClr val="4A5568"/>
                           </a:solidFill>
@@ -5789,7 +5789,7 @@
                         </a:lnSpc>
                       </a:pPr>
                       <a:r>
-                        <a:rPr sz="1000" b="1">
+                        <a:rPr sz="950" b="1">
                           <a:solidFill>
                             <a:srgbClr val="0B1F3A"/>
                           </a:solidFill>
@@ -5816,7 +5816,7 @@
                         </a:lnSpc>
                       </a:pPr>
                       <a:r>
-                        <a:rPr sz="1000" b="0">
+                        <a:rPr sz="950" b="0">
                           <a:solidFill>
                             <a:srgbClr val="4A5568"/>
                           </a:solidFill>
@@ -5843,13 +5843,13 @@
                         </a:lnSpc>
                       </a:pPr>
                       <a:r>
-                        <a:rPr sz="1000" b="0">
+                        <a:rPr sz="950" b="0">
                           <a:solidFill>
                             <a:srgbClr val="4A5568"/>
                           </a:solidFill>
                           <a:latin typeface="Segoe UI"/>
                         </a:rPr>
-                        <a:t>FR-01, FR-02, FR-06, FR-14</a:t>
+                        <a:t>FR-01, FR-02, FR-06, FR-14, FR-19</a:t>
                       </a:r>
                     </a:p>
                   </a:txBody>
@@ -5872,7 +5872,7 @@
                         </a:lnSpc>
                       </a:pPr>
                       <a:r>
-                        <a:rPr sz="1000" b="1">
+                        <a:rPr sz="950" b="1">
                           <a:solidFill>
                             <a:srgbClr val="0B1F3A"/>
                           </a:solidFill>
@@ -5899,7 +5899,7 @@
                         </a:lnSpc>
                       </a:pPr>
                       <a:r>
-                        <a:rPr sz="1000" b="0">
+                        <a:rPr sz="950" b="0">
                           <a:solidFill>
                             <a:srgbClr val="4A5568"/>
                           </a:solidFill>
@@ -5926,7 +5926,7 @@
                         </a:lnSpc>
                       </a:pPr>
                       <a:r>
-                        <a:rPr sz="1000" b="0">
+                        <a:rPr sz="950" b="0">
                           <a:solidFill>
                             <a:srgbClr val="4A5568"/>
                           </a:solidFill>
@@ -5955,7 +5955,7 @@
                         </a:lnSpc>
                       </a:pPr>
                       <a:r>
-                        <a:rPr sz="1000" b="1">
+                        <a:rPr sz="950" b="1">
                           <a:solidFill>
                             <a:srgbClr val="0B1F3A"/>
                           </a:solidFill>
@@ -5982,7 +5982,7 @@
                         </a:lnSpc>
                       </a:pPr>
                       <a:r>
-                        <a:rPr sz="1000" b="0">
+                        <a:rPr sz="950" b="0">
                           <a:solidFill>
                             <a:srgbClr val="4A5568"/>
                           </a:solidFill>
@@ -6009,7 +6009,7 @@
                         </a:lnSpc>
                       </a:pPr>
                       <a:r>
-                        <a:rPr sz="1000" b="0">
+                        <a:rPr sz="950" b="0">
                           <a:solidFill>
                             <a:srgbClr val="4A5568"/>
                           </a:solidFill>
@@ -6038,7 +6038,7 @@
                         </a:lnSpc>
                       </a:pPr>
                       <a:r>
-                        <a:rPr sz="1000" b="1">
+                        <a:rPr sz="950" b="1">
                           <a:solidFill>
                             <a:srgbClr val="0B1F3A"/>
                           </a:solidFill>
@@ -6065,7 +6065,7 @@
                         </a:lnSpc>
                       </a:pPr>
                       <a:r>
-                        <a:rPr sz="1000" b="0">
+                        <a:rPr sz="950" b="0">
                           <a:solidFill>
                             <a:srgbClr val="4A5568"/>
                           </a:solidFill>
@@ -6092,7 +6092,7 @@
                         </a:lnSpc>
                       </a:pPr>
                       <a:r>
-                        <a:rPr sz="1000" b="0">
+                        <a:rPr sz="950" b="0">
                           <a:solidFill>
                             <a:srgbClr val="4A5568"/>
                           </a:solidFill>
@@ -6121,7 +6121,7 @@
                         </a:lnSpc>
                       </a:pPr>
                       <a:r>
-                        <a:rPr sz="1000" b="1">
+                        <a:rPr sz="950" b="1">
                           <a:solidFill>
                             <a:srgbClr val="0B1F3A"/>
                           </a:solidFill>
@@ -6148,7 +6148,7 @@
                         </a:lnSpc>
                       </a:pPr>
                       <a:r>
-                        <a:rPr sz="1000" b="0">
+                        <a:rPr sz="950" b="0">
                           <a:solidFill>
                             <a:srgbClr val="4A5568"/>
                           </a:solidFill>
@@ -6175,7 +6175,7 @@
                         </a:lnSpc>
                       </a:pPr>
                       <a:r>
-                        <a:rPr sz="1000" b="0">
+                        <a:rPr sz="950" b="0">
                           <a:solidFill>
                             <a:srgbClr val="4A5568"/>
                           </a:solidFill>
@@ -6204,7 +6204,7 @@
                         </a:lnSpc>
                       </a:pPr>
                       <a:r>
-                        <a:rPr sz="1000" b="1">
+                        <a:rPr sz="950" b="1">
                           <a:solidFill>
                             <a:srgbClr val="0B1F3A"/>
                           </a:solidFill>
@@ -6231,7 +6231,7 @@
                         </a:lnSpc>
                       </a:pPr>
                       <a:r>
-                        <a:rPr sz="1000" b="0">
+                        <a:rPr sz="950" b="0">
                           <a:solidFill>
                             <a:srgbClr val="4A5568"/>
                           </a:solidFill>
@@ -6258,7 +6258,7 @@
                         </a:lnSpc>
                       </a:pPr>
                       <a:r>
-                        <a:rPr sz="1000" b="0">
+                        <a:rPr sz="950" b="0">
                           <a:solidFill>
                             <a:srgbClr val="4A5568"/>
                           </a:solidFill>
@@ -6287,7 +6287,7 @@
                         </a:lnSpc>
                       </a:pPr>
                       <a:r>
-                        <a:rPr sz="1000" b="1">
+                        <a:rPr sz="950" b="1">
                           <a:solidFill>
                             <a:srgbClr val="0B1F3A"/>
                           </a:solidFill>
@@ -6314,7 +6314,7 @@
                         </a:lnSpc>
                       </a:pPr>
                       <a:r>
-                        <a:rPr sz="1000" b="0">
+                        <a:rPr sz="950" b="0">
                           <a:solidFill>
                             <a:srgbClr val="4A5568"/>
                           </a:solidFill>
@@ -6341,7 +6341,7 @@
                         </a:lnSpc>
                       </a:pPr>
                       <a:r>
-                        <a:rPr sz="1000" b="0">
+                        <a:rPr sz="950" b="0">
                           <a:solidFill>
                             <a:srgbClr val="4A5568"/>
                           </a:solidFill>

</xml_diff>